<commit_message>
Enforced delete user privilege to admin@gmail.com and handled ORA-02292 integrity constraint gracefully
</commit_message>
<xml_diff>
--- a/Online_Shopping_Management_System_Presentation_Updated.pptx
+++ b/Online_Shopping_Management_System_Presentation_Updated.pptx
@@ -4966,7 +4966,7 @@
                 </a:solidFill>
                 <a:latin typeface="Segoe UI"/>
               </a:rPr>
-              <a:t>•  Security Standards: </a:t>
+              <a:t>•  Branded &amp; Web-like UI: </a:t>
             </a:r>
             <a:r>
               <a:rPr sz="1500">
@@ -4975,7 +4975,7 @@
                 </a:solidFill>
                 <a:latin typeface="Segoe UI"/>
               </a:rPr>
-              <a:t>Enforces authentication checks. Default testing credentials are deleted so entry boxes load blank, requiring manual logins.</a:t>
+              <a:t>Integrates custom circular brand logos in the login and sidebar, features responsive hover animations, and organizes KPIs in grid cards with colored icon badges.</a:t>
             </a:r>
           </a:p>
           <a:p>
@@ -4991,7 +4991,7 @@
                 </a:solidFill>
                 <a:latin typeface="Segoe UI"/>
               </a:rPr>
-              <a:t>•  Interactive Subviews: </a:t>
+              <a:t>•  Security Standards: </a:t>
             </a:r>
             <a:r>
               <a:rPr sz="1500">
@@ -5000,7 +5000,7 @@
                 </a:solidFill>
                 <a:latin typeface="Segoe UI"/>
               </a:rPr>
-              <a:t>Includes multi-column catalog lists, an admin inventory editor, audit logs table grids, and popup transaction receipts.</a:t>
+              <a:t>Enforces authentication checks. Default testing credentials are deleted so entry boxes load blank, requiring manual logins.</a:t>
             </a:r>
           </a:p>
         </p:txBody>

</xml_diff>

<commit_message>
Updated project reports and presentation slides to reflect delete user constraints
</commit_message>
<xml_diff>
--- a/Online_Shopping_Management_System_Presentation_Updated.pptx
+++ b/Online_Shopping_Management_System_Presentation_Updated.pptx
@@ -4941,7 +4941,7 @@
                 </a:solidFill>
                 <a:latin typeface="Segoe UI"/>
               </a:rPr>
-              <a:t>•  User Details Editor: </a:t>
+              <a:t>•  User Details &amp; Deletion: </a:t>
             </a:r>
             <a:r>
               <a:rPr sz="1500">
@@ -4950,7 +4950,7 @@
                 </a:solidFill>
                 <a:latin typeface="Segoe UI"/>
               </a:rPr>
-              <a:t>Allows admins to update customer profiles (Full Name, Email Address, and Hashed Password) via sidebar entries.</a:t>
+              <a:t>Allows profile updates. Only 'admin@gmail.com' can delete accounts, with active ORA-02292 integrity constraint checks to handle order links gracefully.</a:t>
             </a:r>
           </a:p>
           <a:p>

</xml_diff>